<commit_message>
Open the demo on the account view, not the side-by-side
The demo led with one probe across three memory layers, which is the proof but
not the point — it asks the room to infer the product from an example. The
account view states it: every fact that moved in this client's file, and
whether the assistant kept up. Lead with that, then drill into a single
failure for the evidence.

Two beats are new. The risk appetite flipping aggressive to conservative, with
ten answers still coming back aggressive from two of the three layers. And the
inferred card — crypto exposure going to "no" because the subsidiary holding
it was divested, never stated anywhere, which no keyword search would catch
and the answer key does.

Slide 5's four on-slide steps are relabelled to match the new order. The
pre-flight note now says which tab to have open.

PITCH_SCRIPT.md is regenerated from the deck's notes, as its header says to.

Co-Authored-By: Claude Opus 5 <noreply@anthropic.com>
</commit_message>
<xml_diff>
--- a/TraceWise_AI_Broader_Pitch.pptx
+++ b/TraceWise_AI_Broader_Pitch.pptx
@@ -1114,37 +1114,67 @@
           <a:p/>
           <a:p>
             <a:r>
-              <a:t>(Show: old fact, the correction, the probe.)</a:t>
+              <a:t>(RECOMMENDATION TAB. Lead with this - it is the whole product in one screen.)</a:t>
             </a:r>
           </a:p>
           <a:p/>
           <a:p>
             <a:r>
-              <a:t>"Same question, three memory layers, side by side. Here's what each one actually answered. Here's what the dated answer key says was true in April."</a:t>
+              <a:t>"This is every fact that moved in this client's file, and whether the assistant kept up.</a:t>
             </a:r>
           </a:p>
           <a:p/>
           <a:p>
             <a:r>
-              <a:t>(Open one real failure.)</a:t>
+              <a:t>Top of the list: risk appetite, aggressive to conservative, changed in March. Ten answers still came back aggressive. Two of the three memory layers are still quoting the old value."</a:t>
             </a:r>
           </a:p>
           <a:p/>
           <a:p>
             <a:r>
-              <a:t>"And this is the part that matters for governance - not just that it's wrong, but the exact context the memory layer handed the model. That's the evidence an assurance team needs to act."</a:t>
+              <a:t>(POINT AT THE INFERRED CARD - crypto exposure.)</a:t>
             </a:r>
           </a:p>
           <a:p/>
           <a:p>
             <a:r>
+              <a:t>"And this one was never stated anywhere. The client divested the subsidiary that held the crypto, so the exposure went to no by inference. No keyword search finds that. The answer key knows it, so we can test it."</a:t>
+            </a:r>
+          </a:p>
+          <a:p/>
+          <a:p>
+            <a:r>
+              <a:t>(SIDE-BY-SIDE. Now drill into one.)</a:t>
+            </a:r>
+          </a:p>
+          <a:p/>
+          <a:p>
+            <a:r>
+              <a:t>"Same question, three memory layers. Here is what each one actually answered, against what was true in April."</a:t>
+            </a:r>
+          </a:p>
+          <a:p/>
+          <a:p>
+            <a:r>
+              <a:t>(OPEN ONE REAL FAILURE.)</a:t>
+            </a:r>
+          </a:p>
+          <a:p/>
+          <a:p>
+            <a:r>
+              <a:t>"And this is what matters for governance - not just that it is wrong, but the exact context the memory layer handed the model. That is the evidence an assurance team needs to act."</a:t>
+            </a:r>
+          </a:p>
+          <a:p/>
+          <a:p>
+            <a:r>
               <a:t>IF THE DEMO MISBEHAVES: "the committed run is in the repo and the dashboard opens on it" - then go to slide 7. Do not debug on stage.</a:t>
             </a:r>
           </a:p>
           <a:p/>
           <a:p>
             <a:r>
-              <a:t>BEFORE YOU START: have the dashboard already open on the Opus run in a second tab.</a:t>
+              <a:t>BEFORE YOU START: dashboard open on the Opus run, Recommendation tab already selected.</a:t>
             </a:r>
           </a:p>
         </p:txBody>
@@ -7597,7 +7627,7 @@
                 <a:ea typeface="Aptos" pitchFamily="34" charset="-122"/>
                 <a:cs typeface="Aptos" pitchFamily="34" charset="-120"/>
               </a:rPr>
-              <a:t>One probe, all systems</a:t>
+              <a:t>What changed, and who missed it</a:t>
             </a:r>
             <a:endParaRPr lang="en-US" sz="1520" dirty="0"/>
           </a:p>
@@ -7710,7 +7740,7 @@
                 <a:ea typeface="Aptos" pitchFamily="34" charset="-122"/>
                 <a:cs typeface="Aptos" pitchFamily="34" charset="-120"/>
               </a:rPr>
-              <a:t>Open a real failure</a:t>
+              <a:t>One probe, all systems</a:t>
             </a:r>
             <a:endParaRPr lang="en-US" sz="1520" dirty="0"/>
           </a:p>
@@ -7823,7 +7853,7 @@
                 <a:ea typeface="Aptos" pitchFamily="34" charset="-122"/>
                 <a:cs typeface="Aptos" pitchFamily="34" charset="-120"/>
               </a:rPr>
-              <a:t>Inspect the evidence</a:t>
+              <a:t>Open a failure, see its evidence</a:t>
             </a:r>
             <a:endParaRPr lang="en-US" sz="1520" dirty="0"/>
           </a:p>

</xml_diff>